<commit_message>
Show real slide numbers instead of field placeholder
Co-Authored-By: Claude Sonnet 5.5 <noreply@anthropic.com>
Claude-Session: https://claude.ai/code/session_01TyFKmLJqyxNygHvjK9ydxU
</commit_message>
<xml_diff>
--- a/Birlesik_Iki_Makale_Ozet.pptx
+++ b/Birlesik_Iki_Makale_Ozet.pptx
@@ -3618,7 +3618,7 @@
           <a:p>
             <a:fld id="{F302176B-0E47-46AC-8F43-DAB4B8A37D06}" type="slidenum">
               <a:rPr lang="tr-TR" smtClean="0"/>
-              <a:t>‹#›</a:t>
+              <a:t>1</a:t>
             </a:fld>
             <a:endParaRPr lang="tr-TR"/>
           </a:p>
@@ -3777,7 +3777,7 @@
           <a:p>
             <a:fld id="{F302176B-0E47-46AC-8F43-DAB4B8A37D06}" type="slidenum">
               <a:rPr lang="tr-TR" smtClean="0"/>
-              <a:t>‹#›</a:t>
+              <a:t>10</a:t>
             </a:fld>
             <a:endParaRPr lang="tr-TR"/>
           </a:p>
@@ -3899,7 +3899,7 @@
           <a:p>
             <a:fld id="{F302176B-0E47-46AC-8F43-DAB4B8A37D06}" type="slidenum">
               <a:rPr lang="tr-TR" smtClean="0"/>
-              <a:t>‹#›</a:t>
+              <a:t>11</a:t>
             </a:fld>
             <a:endParaRPr lang="tr-TR"/>
           </a:p>
@@ -4047,7 +4047,7 @@
           <a:p>
             <a:fld id="{F302176B-0E47-46AC-8F43-DAB4B8A37D06}" type="slidenum">
               <a:rPr lang="tr-TR" smtClean="0"/>
-              <a:t>‹#›</a:t>
+              <a:t>12</a:t>
             </a:fld>
             <a:endParaRPr lang="tr-TR"/>
           </a:p>
@@ -4206,7 +4206,7 @@
           <a:p>
             <a:fld id="{F302176B-0E47-46AC-8F43-DAB4B8A37D06}" type="slidenum">
               <a:rPr lang="tr-TR" smtClean="0"/>
-              <a:t>‹#›</a:t>
+              <a:t>13</a:t>
             </a:fld>
             <a:endParaRPr lang="tr-TR"/>
           </a:p>
@@ -4341,7 +4341,7 @@
           <a:p>
             <a:fld id="{F302176B-0E47-46AC-8F43-DAB4B8A37D06}" type="slidenum">
               <a:rPr lang="tr-TR" smtClean="0"/>
-              <a:t>‹#›</a:t>
+              <a:t>14</a:t>
             </a:fld>
             <a:endParaRPr lang="tr-TR"/>
           </a:p>
@@ -4695,7 +4695,7 @@
           <a:p>
             <a:fld id="{F302176B-0E47-46AC-8F43-DAB4B8A37D06}" type="slidenum">
               <a:rPr lang="tr-TR" smtClean="0"/>
-              <a:t>‹#›</a:t>
+              <a:t>15</a:t>
             </a:fld>
             <a:endParaRPr lang="tr-TR"/>
           </a:p>
@@ -4816,7 +4816,7 @@
           <a:p>
             <a:fld id="{F302176B-0E47-46AC-8F43-DAB4B8A37D06}" type="slidenum">
               <a:rPr lang="tr-TR" smtClean="0"/>
-              <a:t>‹#›</a:t>
+              <a:t>16</a:t>
             </a:fld>
             <a:endParaRPr lang="tr-TR"/>
           </a:p>
@@ -4951,7 +4951,7 @@
           <a:p>
             <a:fld id="{F302176B-0E47-46AC-8F43-DAB4B8A37D06}" type="slidenum">
               <a:rPr lang="tr-TR" smtClean="0"/>
-              <a:t>‹#›</a:t>
+              <a:t>17</a:t>
             </a:fld>
             <a:endParaRPr lang="tr-TR"/>
           </a:p>
@@ -5325,7 +5325,7 @@
           <a:p>
             <a:fld id="{F302176B-0E47-46AC-8F43-DAB4B8A37D06}" type="slidenum">
               <a:rPr lang="tr-TR" smtClean="0"/>
-              <a:t>‹#›</a:t>
+              <a:t>18</a:t>
             </a:fld>
             <a:endParaRPr lang="tr-TR"/>
           </a:p>
@@ -5499,7 +5499,7 @@
           <a:p>
             <a:fld id="{F302176B-0E47-46AC-8F43-DAB4B8A37D06}" type="slidenum">
               <a:rPr lang="tr-TR" smtClean="0"/>
-              <a:t>‹#›</a:t>
+              <a:t>19</a:t>
             </a:fld>
             <a:endParaRPr lang="tr-TR"/>
           </a:p>
@@ -5639,7 +5639,7 @@
           <a:p>
             <a:fld id="{F302176B-0E47-46AC-8F43-DAB4B8A37D06}" type="slidenum">
               <a:rPr lang="tr-TR" smtClean="0"/>
-              <a:t>‹#›</a:t>
+              <a:t>2</a:t>
             </a:fld>
             <a:endParaRPr lang="tr-TR"/>
           </a:p>
@@ -5763,7 +5763,7 @@
           <a:p>
             <a:fld id="{F302176B-0E47-46AC-8F43-DAB4B8A37D06}" type="slidenum">
               <a:rPr lang="tr-TR" smtClean="0"/>
-              <a:t>‹#›</a:t>
+              <a:t>20</a:t>
             </a:fld>
             <a:endParaRPr lang="tr-TR"/>
           </a:p>
@@ -5898,7 +5898,7 @@
           <a:p>
             <a:fld id="{F302176B-0E47-46AC-8F43-DAB4B8A37D06}" type="slidenum">
               <a:rPr lang="tr-TR" smtClean="0"/>
-              <a:t>‹#›</a:t>
+              <a:t>3</a:t>
             </a:fld>
             <a:endParaRPr lang="tr-TR"/>
           </a:p>
@@ -6057,7 +6057,7 @@
           <a:p>
             <a:fld id="{F302176B-0E47-46AC-8F43-DAB4B8A37D06}" type="slidenum">
               <a:rPr lang="tr-TR" smtClean="0"/>
-              <a:t>‹#›</a:t>
+              <a:t>4</a:t>
             </a:fld>
             <a:endParaRPr lang="tr-TR"/>
           </a:p>
@@ -6197,7 +6197,7 @@
           <a:p>
             <a:fld id="{F302176B-0E47-46AC-8F43-DAB4B8A37D06}" type="slidenum">
               <a:rPr lang="tr-TR" smtClean="0"/>
-              <a:t>‹#›</a:t>
+              <a:t>5</a:t>
             </a:fld>
             <a:endParaRPr lang="tr-TR"/>
           </a:p>
@@ -6332,7 +6332,7 @@
           <a:p>
             <a:fld id="{F302176B-0E47-46AC-8F43-DAB4B8A37D06}" type="slidenum">
               <a:rPr lang="tr-TR" smtClean="0"/>
-              <a:t>‹#›</a:t>
+              <a:t>6</a:t>
             </a:fld>
             <a:endParaRPr lang="tr-TR"/>
           </a:p>
@@ -6858,7 +6858,7 @@
           <a:p>
             <a:fld id="{F302176B-0E47-46AC-8F43-DAB4B8A37D06}" type="slidenum">
               <a:rPr lang="tr-TR" smtClean="0"/>
-              <a:t>‹#›</a:t>
+              <a:t>7</a:t>
             </a:fld>
             <a:endParaRPr lang="tr-TR"/>
           </a:p>
@@ -7006,7 +7006,7 @@
           <a:p>
             <a:fld id="{F302176B-0E47-46AC-8F43-DAB4B8A37D06}" type="slidenum">
               <a:rPr lang="tr-TR" smtClean="0"/>
-              <a:t>‹#›</a:t>
+              <a:t>8</a:t>
             </a:fld>
             <a:endParaRPr lang="tr-TR"/>
           </a:p>
@@ -7115,7 +7115,7 @@
           <a:p>
             <a:fld id="{F302176B-0E47-46AC-8F43-DAB4B8A37D06}" type="slidenum">
               <a:rPr lang="tr-TR" smtClean="0"/>
-              <a:t>‹#›</a:t>
+              <a:t>9</a:t>
             </a:fld>
             <a:endParaRPr lang="tr-TR"/>
           </a:p>

</xml_diff>